<commit_message>
feat(charvolin): nouveau partenaire Assurance Charvolin (Allianz)
- Base Supabase : fiche partenaire pt-charvolin (adresse, tel +33 4 93 58 41 41, GPS 43.7244/7.1028, logo, site Allianz) -> apparait dans la carte v_nds_commerces_carte. Event ev-nds-charvolin cree (duplique de giordano, qr_token unique, jeu fonctionnel).
- A4 : PNG + SVG + PPTX 100% editable (decompose) + PDF dans kit-digital/charvolin/. QR ev-nds-charvolin. README + zip. Bloc ajoute a index.html.
- Forex : 7e logo (Allianz Charvolin) dans la bande NOS PARTENAIRES, re-render 6 forex (PNG+PDF), SVG caisses, kit-nds.zip.
- Tel recupere via Google Places (l'email ne le contenait pas).
- RESTE : insertion dans la video ecran (scene partenaires, layout a 7 logos) + lancement jeu.
</commit_message>
<xml_diff>
--- a/admin/public/nds/kit-digital/charvolin/nds_a4_charvolin-editable.pptx
+++ b/admin/public/nds/kit-digital/charvolin/nds_a4_charvolin-editable.pptx
@@ -1302,8 +1302,8 @@
         </p:nvSpPr>
         <p:spPr>
           <a:xfrm>
-            <a:off x="0" y="8364303"/>
-            <a:ext cx="7559040" cy="550286"/>
+            <a:off x="0" y="8323369"/>
+            <a:ext cx="7559040" cy="632155"/>
           </a:xfrm>
           <a:prstGeom prst="rect">
             <a:avLst/>
@@ -1319,7 +1319,7 @@
               <a:buNone/>
             </a:pPr>
             <a:r>
-              <a:rPr lang="en-US" sz="2549" b="1" dirty="0">
+              <a:rPr lang="en-US" sz="2928" b="1" dirty="0">
                 <a:solidFill>
                   <a:srgbClr val="FFFFFF"/>
                 </a:solidFill>
@@ -1329,7 +1329,7 @@
               </a:rPr>
               <a:t>+ VOUS JOUEZ + VOS CHANCES AUGMENTENT</a:t>
             </a:r>
-            <a:endParaRPr lang="en-US" sz="2549" dirty="0"/>
+            <a:endParaRPr lang="en-US" sz="2928" dirty="0"/>
           </a:p>
         </p:txBody>
       </p:sp>

</xml_diff>